<commit_message>
Expand the next-step section into three slides
Slide 19 now points into a dedicated section instead of compressing the
plan into one sentence:

- Slide 20: the next step in three stages (settle the feature
  definitions, test whether the coverage gaps are systematic, then
  extend the window and the country set), with the reason for that order.
- Slide 21: the planned logistic regression explained in plain terms —
  what the model is, the yes/no outcome (does a district-month have
  market price data, and separately reporting), the explanatory
  variables, and why it goes beyond the one-variable-at-a-time test in
  pilot analysis 1.
- Slide 22: what either result would mean for the dissertation, and what
  the model cannot say (a record existing is not the same as conditions
  being observed).

Slide 19's wording simplified accordingly. PDF re-exported.

Co-Authored-By: Claude Opus 5 <noreply@anthropic.com>
Claude-Session: https://claude.ai/code/session_015LzojMEgoLSp3JrSr3464c
</commit_message>
<xml_diff>
--- a/weekly_meetings/2026_08_03_slides.pptx
+++ b/weekly_meetings/2026_08_03_slides.pptx
@@ -27,6 +27,9 @@
     <p:sldId id="272" r:id="rId18"/>
     <p:sldId id="273" r:id="rId19"/>
     <p:sldId id="274" r:id="rId20"/>
+    <p:sldId id="275" r:id="rId26"/>
+    <p:sldId id="276" r:id="rId27"/>
+    <p:sldId id="277" r:id="rId28"/>
   </p:sldIdLst>
   <p:sldSz cx="12192000" cy="6858000"/>
   <p:notesSz cx="6858000" cy="12192000"/>
@@ -12142,7 +12145,7 @@
                 <a:ea typeface="Calibri" pitchFamily="34" charset="-122"/>
                 <a:cs typeface="Calibri" pitchFamily="34" charset="-120"/>
               </a:rPr>
-              <a:t>The pipeline is validated. The next step is to make the prototype more robust, not to declare it finished.</a:t>
+              <a:t>The pipeline works end to end. The next step is to make it trustworthy, not to call it finished.</a:t>
             </a:r>
             <a:endParaRPr lang="en-US" sz="1500" dirty="0"/>
           </a:p>
@@ -12521,8 +12524,8 @@
         </p:nvSpPr>
         <p:spPr>
           <a:xfrm>
-            <a:off x="8549640" y="2651760"/>
-            <a:ext cx="1737360" cy="1077163"/>
+            <a:off x="8366760" y="2651760"/>
+            <a:ext cx="2103120" cy="1077163"/>
           </a:xfrm>
           <a:prstGeom prst="rect">
             <a:avLst/>
@@ -12585,7 +12588,7 @@
                 <a:ea typeface="Calibri" pitchFamily="34" charset="-122"/>
                 <a:cs typeface="Calibri" pitchFamily="34" charset="-120"/>
               </a:rPr>
-              <a:t>next: extend the</a:t>
+              <a:t>next: more months,</a:t>
             </a:r>
             <a:endParaRPr lang="en-US" sz="1200" dirty="0"/>
           </a:p>
@@ -12602,7 +12605,7 @@
                 <a:ea typeface="Calibri" pitchFamily="34" charset="-122"/>
                 <a:cs typeface="Calibri" pitchFamily="34" charset="-120"/>
               </a:rPr>
-              <a:t>window beyond 2</a:t>
+              <a:t>once the checks pass</a:t>
             </a:r>
             <a:endParaRPr lang="en-US" sz="1200" dirty="0"/>
           </a:p>
@@ -12678,7 +12681,7 @@
                 <a:ea typeface="Calibri" pitchFamily="34" charset="-122"/>
                 <a:cs typeface="Calibri" pitchFamily="34" charset="-120"/>
               </a:rPr>
-              <a:t>add more months of data to increase statistical power, re-test both pilot findings on a larger sample, and look for further meaningful extractions the current 2-month window is too short to surface — before scaling to the full 2015–2024, four-country study.</a:t>
+              <a:t>three stages — settle the feature definitions, test whether the missing data falls on one kind of district, and only then extend the time window, ahead of any move to the full 2015–2024, four-country study. The next three slides explain each stage.</a:t>
             </a:r>
             <a:endParaRPr lang="en-US" sz="1350" dirty="0"/>
           </a:p>
@@ -13455,6 +13458,1639 @@
                 <a:cs typeface="Calibri" pitchFamily="34" charset="-120"/>
               </a:rPr>
               <a:t>2</a:t>
+            </a:r>
+            <a:endParaRPr lang="en-US" sz="1000" dirty="0"/>
+          </a:p>
+        </p:txBody>
+      </p:sp>
+    </p:spTree>
+  </p:cSld>
+  <p:clrMapOvr>
+    <a:masterClrMapping/>
+  </p:clrMapOvr>
+</p:sld>
+</file>
+
+<file path=ppt/slides/slide20.xml><?xml version="1.0" encoding="utf-8"?>
+<p:sld xmlns:a="http://schemas.openxmlformats.org/drawingml/2006/main" xmlns:r="http://schemas.openxmlformats.org/officeDocument/2006/relationships" xmlns:p="http://schemas.openxmlformats.org/presentationml/2006/main">
+  <p:cSld>
+    <p:bg>
+      <p:bgPr>
+        <a:solidFill>
+          <a:srgbClr val="FFFFFF"/>
+        </a:solidFill>
+        <a:effectLst/>
+      </p:bgPr>
+    </p:bg>
+    <p:spTree>
+      <p:nvGrpSpPr>
+        <p:cNvPr id="1" name=""/>
+        <p:cNvGrpSpPr/>
+        <p:nvPr/>
+      </p:nvGrpSpPr>
+      <p:grpSpPr>
+        <a:xfrm>
+          <a:off x="0" y="0"/>
+          <a:ext cx="0" cy="0"/>
+          <a:chOff x="0" y="0"/>
+          <a:chExt cx="0" cy="0"/>
+        </a:xfrm>
+      </p:grpSpPr>
+      <p:sp>
+        <p:nvSpPr>
+          <p:cNvPr id="2" name="Text 2"/>
+          <p:cNvSpPr/>
+          <p:nvPr/>
+        </p:nvSpPr>
+        <p:spPr>
+          <a:xfrm>
+            <a:off x="548640" y="411480"/>
+            <a:ext cx="11091672" cy="640080"/>
+          </a:xfrm>
+          <a:prstGeom prst="rect">
+            <a:avLst/>
+          </a:prstGeom>
+          <a:noFill/>
+          <a:ln/>
+        </p:spPr>
+        <p:txBody>
+          <a:bodyPr wrap="square" lIns="0" tIns="0" rIns="0" bIns="0" rtlCol="0" anchor="ctr"/>
+          <a:lstStyle/>
+          <a:p>
+            <a:pPr marL="0" indent="0">
+              <a:buNone/>
+            </a:pPr>
+            <a:r>
+              <a:rPr lang="en-US" sz="2800" b="1" dirty="0">
+                <a:solidFill>
+                  <a:srgbClr val="1B3A4B"/>
+                </a:solidFill>
+                <a:latin typeface="Cambria" pitchFamily="34" charset="0"/>
+                <a:ea typeface="Cambria" pitchFamily="34" charset="-122"/>
+                <a:cs typeface="Cambria" pitchFamily="34" charset="-120"/>
+              </a:rPr>
+              <a:t>The next step, in three stages</a:t>
+            </a:r>
+            <a:endParaRPr lang="en-US" sz="2800" dirty="0"/>
+          </a:p>
+        </p:txBody>
+      </p:sp>
+      <p:sp>
+        <p:nvSpPr>
+          <p:cNvPr id="3" name="Text 3"/>
+          <p:cNvSpPr/>
+          <p:nvPr/>
+        </p:nvSpPr>
+        <p:spPr>
+          <a:xfrm>
+            <a:off x="548640" y="969264"/>
+            <a:ext cx="11091672" cy="365760"/>
+          </a:xfrm>
+          <a:prstGeom prst="rect">
+            <a:avLst/>
+          </a:prstGeom>
+          <a:noFill/>
+          <a:ln/>
+        </p:spPr>
+        <p:txBody>
+          <a:bodyPr wrap="square" lIns="0" tIns="0" rIns="0" bIns="0" rtlCol="0" anchor="ctr"/>
+          <a:lstStyle/>
+          <a:p>
+            <a:pPr marL="0" indent="0">
+              <a:buNone/>
+            </a:pPr>
+            <a:r>
+              <a:rPr lang="en-US" sz="1350" dirty="0">
+                <a:solidFill>
+                  <a:srgbClr val="5B6B73"/>
+                </a:solidFill>
+                <a:latin typeface="Calibri" pitchFamily="34" charset="0"/>
+                <a:ea typeface="Calibri" pitchFamily="34" charset="-122"/>
+                <a:cs typeface="Calibri" pitchFamily="34" charset="-120"/>
+              </a:rPr>
+              <a:t>All three answer one question: how evenly do the four sources observe different districts?</a:t>
+            </a:r>
+            <a:endParaRPr lang="en-US" sz="1350" dirty="0"/>
+          </a:p>
+        </p:txBody>
+      </p:sp>
+      <p:sp>
+        <p:nvSpPr>
+          <p:cNvPr id="4" name="Shape 4"/>
+          <p:cNvSpPr/>
+          <p:nvPr/>
+        </p:nvSpPr>
+        <p:spPr>
+          <a:xfrm>
+            <a:off x="548640" y="1678288"/>
+            <a:ext cx="128016" cy="128016"/>
+          </a:xfrm>
+          <a:prstGeom prst="ellipse">
+            <a:avLst/>
+          </a:prstGeom>
+          <a:solidFill>
+            <a:srgbClr val="C1502F"/>
+          </a:solidFill>
+          <a:ln/>
+        </p:spPr>
+      </p:sp>
+      <p:sp>
+        <p:nvSpPr>
+          <p:cNvPr id="5" name="Text 5"/>
+          <p:cNvSpPr/>
+          <p:nvPr/>
+        </p:nvSpPr>
+        <p:spPr>
+          <a:xfrm>
+            <a:off x="822960" y="1660000"/>
+            <a:ext cx="2011680" cy="457200"/>
+          </a:xfrm>
+          <a:prstGeom prst="rect">
+            <a:avLst/>
+          </a:prstGeom>
+          <a:noFill/>
+          <a:ln/>
+        </p:spPr>
+        <p:txBody>
+          <a:bodyPr wrap="square" lIns="0" tIns="0" rIns="0" bIns="0" rtlCol="0" anchor="t"/>
+          <a:lstStyle/>
+          <a:p>
+            <a:pPr marL="0" indent="0">
+              <a:buNone/>
+            </a:pPr>
+            <a:r>
+              <a:rPr lang="en-US" sz="1200" b="1" kern="0" spc="100" dirty="0">
+                <a:solidFill>
+                  <a:srgbClr val="C1502F"/>
+                </a:solidFill>
+                <a:latin typeface="Calibri" pitchFamily="34" charset="0"/>
+                <a:ea typeface="Calibri" pitchFamily="34" charset="-122"/>
+                <a:cs typeface="Calibri" pitchFamily="34" charset="-120"/>
+              </a:rPr>
+              <a:t>STAGE 1 · NOW</a:t>
+            </a:r>
+            <a:endParaRPr lang="en-US" sz="1200" dirty="0"/>
+          </a:p>
+        </p:txBody>
+      </p:sp>
+      <p:sp>
+        <p:nvSpPr>
+          <p:cNvPr id="6" name="Text 6"/>
+          <p:cNvSpPr/>
+          <p:nvPr/>
+        </p:nvSpPr>
+        <p:spPr>
+          <a:xfrm>
+            <a:off x="3017520" y="1660000"/>
+            <a:ext cx="8503920" cy="1417320"/>
+          </a:xfrm>
+          <a:prstGeom prst="rect">
+            <a:avLst/>
+          </a:prstGeom>
+          <a:noFill/>
+          <a:ln/>
+        </p:spPr>
+        <p:txBody>
+          <a:bodyPr wrap="square" lIns="0" tIns="0" rIns="0" bIns="0" rtlCol="0" anchor="t"/>
+          <a:lstStyle/>
+          <a:p>
+            <a:pPr marL="0" indent="0">
+              <a:lnSpc>
+                <a:spcPct val="125000"/>
+              </a:lnSpc>
+              <a:buNone/>
+            </a:pPr>
+            <a:r>
+              <a:rPr lang="en-US" sz="1300" b="1" dirty="0">
+                <a:solidFill>
+                  <a:srgbClr val="1B3A4B"/>
+                </a:solidFill>
+                <a:latin typeface="Calibri" pitchFamily="34" charset="0"/>
+                <a:ea typeface="Calibri" pitchFamily="34" charset="-122"/>
+                <a:cs typeface="Calibri" pitchFamily="34" charset="-120"/>
+              </a:rPr>
+              <a:t>Make the prototype sound. </a:t>
+            </a:r>
+            <a:r>
+              <a:rPr lang="en-US" sz="1300" dirty="0">
+                <a:solidFill>
+                  <a:srgbClr val="5B6B73"/>
+                </a:solidFill>
+                <a:latin typeface="Calibri" pitchFamily="34" charset="0"/>
+                <a:ea typeface="Calibri" pitchFamily="34" charset="-122"/>
+                <a:cs typeface="Calibri" pitchFamily="34" charset="-120"/>
+              </a:rPr>
+              <a:t>The feature definitions have to be settled before more data is added: hand-check a sample of the ReliefWeb district matches and report how often they are right, widen the name list beyond the 16 districts it covers today, rename conflict density to conflict_events_per_1000_km2 and test whether it adds anything beyond event count and district size, and replace the percentage-change features where the previous month is zero.</a:t>
+            </a:r>
+            <a:endParaRPr lang="en-US" sz="1300" dirty="0"/>
+          </a:p>
+        </p:txBody>
+      </p:sp>
+      <p:sp>
+        <p:nvSpPr>
+          <p:cNvPr id="7" name="Shape 7"/>
+          <p:cNvSpPr/>
+          <p:nvPr/>
+        </p:nvSpPr>
+        <p:spPr>
+          <a:xfrm>
+            <a:off x="548640" y="3228288"/>
+            <a:ext cx="128016" cy="128016"/>
+          </a:xfrm>
+          <a:prstGeom prst="ellipse">
+            <a:avLst/>
+          </a:prstGeom>
+          <a:solidFill>
+            <a:srgbClr val="C1502F"/>
+          </a:solidFill>
+          <a:ln/>
+        </p:spPr>
+      </p:sp>
+      <p:sp>
+        <p:nvSpPr>
+          <p:cNvPr id="8" name="Text 8"/>
+          <p:cNvSpPr/>
+          <p:nvPr/>
+        </p:nvSpPr>
+        <p:spPr>
+          <a:xfrm>
+            <a:off x="822960" y="3210000"/>
+            <a:ext cx="2011680" cy="457200"/>
+          </a:xfrm>
+          <a:prstGeom prst="rect">
+            <a:avLst/>
+          </a:prstGeom>
+          <a:noFill/>
+          <a:ln/>
+        </p:spPr>
+        <p:txBody>
+          <a:bodyPr wrap="square" lIns="0" tIns="0" rIns="0" bIns="0" rtlCol="0" anchor="t"/>
+          <a:lstStyle/>
+          <a:p>
+            <a:pPr marL="0" indent="0">
+              <a:buNone/>
+            </a:pPr>
+            <a:r>
+              <a:rPr lang="en-US" sz="1200" b="1" kern="0" spc="100" dirty="0">
+                <a:solidFill>
+                  <a:srgbClr val="C1502F"/>
+                </a:solidFill>
+                <a:latin typeface="Calibri" pitchFamily="34" charset="0"/>
+                <a:ea typeface="Calibri" pitchFamily="34" charset="-122"/>
+                <a:cs typeface="Calibri" pitchFamily="34" charset="-120"/>
+              </a:rPr>
+              <a:t>STAGE 2 · NEXT</a:t>
+            </a:r>
+            <a:endParaRPr lang="en-US" sz="1200" dirty="0"/>
+          </a:p>
+        </p:txBody>
+      </p:sp>
+      <p:sp>
+        <p:nvSpPr>
+          <p:cNvPr id="9" name="Text 9"/>
+          <p:cNvSpPr/>
+          <p:nvPr/>
+        </p:nvSpPr>
+        <p:spPr>
+          <a:xfrm>
+            <a:off x="3017520" y="3210000"/>
+            <a:ext cx="8503920" cy="1417320"/>
+          </a:xfrm>
+          <a:prstGeom prst="rect">
+            <a:avLst/>
+          </a:prstGeom>
+          <a:noFill/>
+          <a:ln/>
+        </p:spPr>
+        <p:txBody>
+          <a:bodyPr wrap="square" lIns="0" tIns="0" rIns="0" bIns="0" rtlCol="0" anchor="t"/>
+          <a:lstStyle/>
+          <a:p>
+            <a:pPr marL="0" indent="0">
+              <a:lnSpc>
+                <a:spcPct val="125000"/>
+              </a:lnSpc>
+              <a:buNone/>
+            </a:pPr>
+            <a:r>
+              <a:rPr lang="en-US" sz="1300" b="1" dirty="0">
+                <a:solidFill>
+                  <a:srgbClr val="1B3A4B"/>
+                </a:solidFill>
+                <a:latin typeface="Calibri" pitchFamily="34" charset="0"/>
+                <a:ea typeface="Calibri" pitchFamily="34" charset="-122"/>
+                <a:cs typeface="Calibri" pitchFamily="34" charset="-120"/>
+              </a:rPr>
+              <a:t>Test whether the coverage gaps are systematic. </a:t>
+            </a:r>
+            <a:r>
+              <a:rPr lang="en-US" sz="1300" dirty="0">
+                <a:solidFill>
+                  <a:srgbClr val="5B6B73"/>
+                </a:solidFill>
+                <a:latin typeface="Calibri" pitchFamily="34" charset="0"/>
+                <a:ea typeface="Calibri" pitchFamily="34" charset="-122"/>
+                <a:cs typeface="Calibri" pitchFamily="34" charset="-120"/>
+              </a:rPr>
+              <a:t>Market data covers 47% of districts and reporting 60%. The open question is whether the missing district-months are spread evenly, or fall on one kind of district — larger, more rural, or more conflict-affected. Each row is either observed or not, so this is a yes/no question, and it is answered with a logistic regression (next two slides).</a:t>
+            </a:r>
+            <a:endParaRPr lang="en-US" sz="1300" dirty="0"/>
+          </a:p>
+        </p:txBody>
+      </p:sp>
+      <p:sp>
+        <p:nvSpPr>
+          <p:cNvPr id="10" name="Shape 10"/>
+          <p:cNvSpPr/>
+          <p:nvPr/>
+        </p:nvSpPr>
+        <p:spPr>
+          <a:xfrm>
+            <a:off x="548640" y="4778288"/>
+            <a:ext cx="128016" cy="128016"/>
+          </a:xfrm>
+          <a:prstGeom prst="ellipse">
+            <a:avLst/>
+          </a:prstGeom>
+          <a:solidFill>
+            <a:srgbClr val="C1502F"/>
+          </a:solidFill>
+          <a:ln/>
+        </p:spPr>
+      </p:sp>
+      <p:sp>
+        <p:nvSpPr>
+          <p:cNvPr id="11" name="Text 11"/>
+          <p:cNvSpPr/>
+          <p:nvPr/>
+        </p:nvSpPr>
+        <p:spPr>
+          <a:xfrm>
+            <a:off x="822960" y="4760000"/>
+            <a:ext cx="2011680" cy="457200"/>
+          </a:xfrm>
+          <a:prstGeom prst="rect">
+            <a:avLst/>
+          </a:prstGeom>
+          <a:noFill/>
+          <a:ln/>
+        </p:spPr>
+        <p:txBody>
+          <a:bodyPr wrap="square" lIns="0" tIns="0" rIns="0" bIns="0" rtlCol="0" anchor="t"/>
+          <a:lstStyle/>
+          <a:p>
+            <a:pPr marL="0" indent="0">
+              <a:buNone/>
+            </a:pPr>
+            <a:r>
+              <a:rPr lang="en-US" sz="1200" b="1" kern="0" spc="100" dirty="0">
+                <a:solidFill>
+                  <a:srgbClr val="C1502F"/>
+                </a:solidFill>
+                <a:latin typeface="Calibri" pitchFamily="34" charset="0"/>
+                <a:ea typeface="Calibri" pitchFamily="34" charset="-122"/>
+                <a:cs typeface="Calibri" pitchFamily="34" charset="-120"/>
+              </a:rPr>
+              <a:t>STAGE 3 · AFTER</a:t>
+            </a:r>
+            <a:endParaRPr lang="en-US" sz="1200" dirty="0"/>
+          </a:p>
+        </p:txBody>
+      </p:sp>
+      <p:sp>
+        <p:nvSpPr>
+          <p:cNvPr id="12" name="Text 12"/>
+          <p:cNvSpPr/>
+          <p:nvPr/>
+        </p:nvSpPr>
+        <p:spPr>
+          <a:xfrm>
+            <a:off x="3017520" y="4760000"/>
+            <a:ext cx="8503920" cy="1417320"/>
+          </a:xfrm>
+          <a:prstGeom prst="rect">
+            <a:avLst/>
+          </a:prstGeom>
+          <a:noFill/>
+          <a:ln/>
+        </p:spPr>
+        <p:txBody>
+          <a:bodyPr wrap="square" lIns="0" tIns="0" rIns="0" bIns="0" rtlCol="0" anchor="t"/>
+          <a:lstStyle/>
+          <a:p>
+            <a:pPr marL="0" indent="0">
+              <a:lnSpc>
+                <a:spcPct val="125000"/>
+              </a:lnSpc>
+              <a:buNone/>
+            </a:pPr>
+            <a:r>
+              <a:rPr lang="en-US" sz="1300" b="1" dirty="0">
+                <a:solidFill>
+                  <a:srgbClr val="1B3A4B"/>
+                </a:solidFill>
+                <a:latin typeface="Calibri" pitchFamily="34" charset="0"/>
+                <a:ea typeface="Calibri" pitchFamily="34" charset="-122"/>
+                <a:cs typeface="Calibri" pitchFamily="34" charset="-120"/>
+              </a:rPr>
+              <a:t>Extend the window, then the country set. </a:t>
+            </a:r>
+            <a:r>
+              <a:rPr lang="en-US" sz="1300" dirty="0">
+                <a:solidFill>
+                  <a:srgbClr val="5B6B73"/>
+                </a:solidFill>
+                <a:latin typeface="Calibri" pitchFamily="34" charset="0"/>
+                <a:ea typeface="Calibri" pitchFamily="34" charset="-122"/>
+                <a:cs typeface="Calibri" pitchFamily="34" charset="-120"/>
+              </a:rPr>
+              <a:t>Once the checks above hold, add months beyond January–February 2024, re-run both pilot analyses on the larger sample, and only then add Ethiopia, Kenya and South Sudan. Scaling first would multiply naming, currency and boundary problems across four countries before they have been solved in one.</a:t>
+            </a:r>
+            <a:endParaRPr lang="en-US" sz="1300" dirty="0"/>
+          </a:p>
+        </p:txBody>
+      </p:sp>
+      <p:sp>
+        <p:nvSpPr>
+          <p:cNvPr id="13" name="Text 13"/>
+          <p:cNvSpPr/>
+          <p:nvPr/>
+        </p:nvSpPr>
+        <p:spPr>
+          <a:xfrm>
+            <a:off x="548640" y="6035040"/>
+            <a:ext cx="11091672" cy="320040"/>
+          </a:xfrm>
+          <a:prstGeom prst="rect">
+            <a:avLst/>
+          </a:prstGeom>
+          <a:noFill/>
+          <a:ln/>
+        </p:spPr>
+        <p:txBody>
+          <a:bodyPr wrap="square" lIns="0" tIns="0" rIns="0" bIns="0" rtlCol="0" anchor="ctr"/>
+          <a:lstStyle/>
+          <a:p>
+            <a:pPr marL="0" indent="0">
+              <a:buNone/>
+            </a:pPr>
+            <a:r>
+              <a:rPr lang="en-US" sz="1250" i="1" dirty="0">
+                <a:solidFill>
+                  <a:srgbClr val="5B6B73"/>
+                </a:solidFill>
+                <a:latin typeface="Calibri" pitchFamily="34" charset="0"/>
+                <a:ea typeface="Calibri" pitchFamily="34" charset="-122"/>
+                <a:cs typeface="Calibri" pitchFamily="34" charset="-120"/>
+              </a:rPr>
+              <a:t>The order matters: each stage depends on the definitions fixed in the stage before it.</a:t>
+            </a:r>
+            <a:endParaRPr lang="en-US" sz="1250" dirty="0"/>
+          </a:p>
+        </p:txBody>
+      </p:sp>
+      <p:sp>
+        <p:nvSpPr>
+          <p:cNvPr id="14" name="Text 14"/>
+          <p:cNvSpPr/>
+          <p:nvPr/>
+        </p:nvSpPr>
+        <p:spPr>
+          <a:xfrm>
+            <a:off x="11548872" y="6400800"/>
+            <a:ext cx="365760" cy="274320"/>
+          </a:xfrm>
+          <a:prstGeom prst="rect">
+            <a:avLst/>
+          </a:prstGeom>
+          <a:noFill/>
+          <a:ln/>
+        </p:spPr>
+        <p:txBody>
+          <a:bodyPr wrap="square" lIns="0" tIns="0" rIns="0" bIns="0" rtlCol="0" anchor="ctr"/>
+          <a:lstStyle/>
+          <a:p>
+            <a:pPr marL="0" indent="0" algn="r">
+              <a:buNone/>
+            </a:pPr>
+            <a:r>
+              <a:rPr lang="en-US" sz="1000" dirty="0">
+                <a:solidFill>
+                  <a:srgbClr val="5B6B73"/>
+                </a:solidFill>
+                <a:latin typeface="Calibri" pitchFamily="34" charset="0"/>
+                <a:ea typeface="Calibri" pitchFamily="34" charset="-122"/>
+                <a:cs typeface="Calibri" pitchFamily="34" charset="-120"/>
+              </a:rPr>
+              <a:t>20</a:t>
+            </a:r>
+            <a:endParaRPr lang="en-US" sz="1000" dirty="0"/>
+          </a:p>
+        </p:txBody>
+      </p:sp>
+    </p:spTree>
+  </p:cSld>
+  <p:clrMapOvr>
+    <a:masterClrMapping/>
+  </p:clrMapOvr>
+</p:sld>
+</file>
+
+<file path=ppt/slides/slide21.xml><?xml version="1.0" encoding="utf-8"?>
+<p:sld xmlns:a="http://schemas.openxmlformats.org/drawingml/2006/main" xmlns:r="http://schemas.openxmlformats.org/officeDocument/2006/relationships" xmlns:p="http://schemas.openxmlformats.org/presentationml/2006/main">
+  <p:cSld>
+    <p:bg>
+      <p:bgPr>
+        <a:solidFill>
+          <a:srgbClr val="FFFFFF"/>
+        </a:solidFill>
+        <a:effectLst/>
+      </p:bgPr>
+    </p:bg>
+    <p:spTree>
+      <p:nvGrpSpPr>
+        <p:cNvPr id="1" name=""/>
+        <p:cNvGrpSpPr/>
+        <p:nvPr/>
+      </p:nvGrpSpPr>
+      <p:grpSpPr>
+        <a:xfrm>
+          <a:off x="0" y="0"/>
+          <a:ext cx="0" cy="0"/>
+          <a:chOff x="0" y="0"/>
+          <a:chExt cx="0" cy="0"/>
+        </a:xfrm>
+      </p:grpSpPr>
+      <p:sp>
+        <p:nvSpPr>
+          <p:cNvPr id="15" name="Text 15"/>
+          <p:cNvSpPr/>
+          <p:nvPr/>
+        </p:nvSpPr>
+        <p:spPr>
+          <a:xfrm>
+            <a:off x="548640" y="411480"/>
+            <a:ext cx="11091672" cy="640080"/>
+          </a:xfrm>
+          <a:prstGeom prst="rect">
+            <a:avLst/>
+          </a:prstGeom>
+          <a:noFill/>
+          <a:ln/>
+        </p:spPr>
+        <p:txBody>
+          <a:bodyPr wrap="square" lIns="0" tIns="0" rIns="0" bIns="0" rtlCol="0" anchor="ctr"/>
+          <a:lstStyle/>
+          <a:p>
+            <a:pPr marL="0" indent="0">
+              <a:buNone/>
+            </a:pPr>
+            <a:r>
+              <a:rPr lang="en-US" sz="2800" b="1" dirty="0">
+                <a:solidFill>
+                  <a:srgbClr val="1B3A4B"/>
+                </a:solidFill>
+                <a:latin typeface="Cambria" pitchFamily="34" charset="0"/>
+                <a:ea typeface="Cambria" pitchFamily="34" charset="-122"/>
+                <a:cs typeface="Cambria" pitchFamily="34" charset="-120"/>
+              </a:rPr>
+              <a:t>The next analysis: a logistic regression on coverage</a:t>
+            </a:r>
+            <a:endParaRPr lang="en-US" sz="2800" dirty="0"/>
+          </a:p>
+        </p:txBody>
+      </p:sp>
+      <p:sp>
+        <p:nvSpPr>
+          <p:cNvPr id="16" name="Text 16"/>
+          <p:cNvSpPr/>
+          <p:nvPr/>
+        </p:nvSpPr>
+        <p:spPr>
+          <a:xfrm>
+            <a:off x="548640" y="969264"/>
+            <a:ext cx="11091672" cy="365760"/>
+          </a:xfrm>
+          <a:prstGeom prst="rect">
+            <a:avLst/>
+          </a:prstGeom>
+          <a:noFill/>
+          <a:ln/>
+        </p:spPr>
+        <p:txBody>
+          <a:bodyPr wrap="square" lIns="0" tIns="0" rIns="0" bIns="0" rtlCol="0" anchor="ctr"/>
+          <a:lstStyle/>
+          <a:p>
+            <a:pPr marL="0" indent="0">
+              <a:buNone/>
+            </a:pPr>
+            <a:r>
+              <a:rPr lang="en-US" sz="1350" dirty="0">
+                <a:solidFill>
+                  <a:srgbClr val="5B6B73"/>
+                </a:solidFill>
+                <a:latin typeface="Calibri" pitchFamily="34" charset="0"/>
+                <a:ea typeface="Calibri" pitchFamily="34" charset="-122"/>
+                <a:cs typeface="Calibri" pitchFamily="34" charset="-120"/>
+              </a:rPr>
+              <a:t>What the model is, what it would be asked, and why a simpler test is not enough</a:t>
+            </a:r>
+            <a:endParaRPr lang="en-US" sz="1350" dirty="0"/>
+          </a:p>
+        </p:txBody>
+      </p:sp>
+      <p:sp>
+        <p:nvSpPr>
+          <p:cNvPr id="17" name="Shape 17"/>
+          <p:cNvSpPr/>
+          <p:nvPr/>
+        </p:nvSpPr>
+        <p:spPr>
+          <a:xfrm>
+            <a:off x="548640" y="1725168"/>
+            <a:ext cx="128016" cy="128016"/>
+          </a:xfrm>
+          <a:prstGeom prst="ellipse">
+            <a:avLst/>
+          </a:prstGeom>
+          <a:solidFill>
+            <a:srgbClr val="C1502F"/>
+          </a:solidFill>
+          <a:ln/>
+        </p:spPr>
+      </p:sp>
+      <p:sp>
+        <p:nvSpPr>
+          <p:cNvPr id="18" name="Text 18"/>
+          <p:cNvSpPr/>
+          <p:nvPr/>
+        </p:nvSpPr>
+        <p:spPr>
+          <a:xfrm>
+            <a:off x="822960" y="1706880"/>
+            <a:ext cx="2011680" cy="457200"/>
+          </a:xfrm>
+          <a:prstGeom prst="rect">
+            <a:avLst/>
+          </a:prstGeom>
+          <a:noFill/>
+          <a:ln/>
+        </p:spPr>
+        <p:txBody>
+          <a:bodyPr wrap="square" lIns="0" tIns="0" rIns="0" bIns="0" rtlCol="0" anchor="t"/>
+          <a:lstStyle/>
+          <a:p>
+            <a:pPr marL="0" indent="0">
+              <a:buNone/>
+            </a:pPr>
+            <a:r>
+              <a:rPr lang="en-US" sz="1200" b="1" kern="0" spc="100" dirty="0">
+                <a:solidFill>
+                  <a:srgbClr val="C1502F"/>
+                </a:solidFill>
+                <a:latin typeface="Calibri" pitchFamily="34" charset="0"/>
+                <a:ea typeface="Calibri" pitchFamily="34" charset="-122"/>
+                <a:cs typeface="Calibri" pitchFamily="34" charset="-120"/>
+              </a:rPr>
+              <a:t>WHAT IT IS</a:t>
+            </a:r>
+            <a:endParaRPr lang="en-US" sz="1200" dirty="0"/>
+          </a:p>
+        </p:txBody>
+      </p:sp>
+      <p:sp>
+        <p:nvSpPr>
+          <p:cNvPr id="19" name="Text 19"/>
+          <p:cNvSpPr/>
+          <p:nvPr/>
+        </p:nvSpPr>
+        <p:spPr>
+          <a:xfrm>
+            <a:off x="3017520" y="1706880"/>
+            <a:ext cx="8503920" cy="1097280"/>
+          </a:xfrm>
+          <a:prstGeom prst="rect">
+            <a:avLst/>
+          </a:prstGeom>
+          <a:noFill/>
+          <a:ln/>
+        </p:spPr>
+        <p:txBody>
+          <a:bodyPr wrap="square" lIns="0" tIns="0" rIns="0" bIns="0" rtlCol="0" anchor="t"/>
+          <a:lstStyle/>
+          <a:p>
+            <a:pPr marL="0" indent="0">
+              <a:lnSpc>
+                <a:spcPct val="125000"/>
+              </a:lnSpc>
+              <a:buNone/>
+            </a:pPr>
+            <a:r>
+              <a:rPr lang="en-US" sz="1300" dirty="0">
+                <a:solidFill>
+                  <a:srgbClr val="5B6B73"/>
+                </a:solidFill>
+                <a:latin typeface="Calibri" pitchFamily="34" charset="0"/>
+                <a:ea typeface="Calibri" pitchFamily="34" charset="-122"/>
+                <a:cs typeface="Calibri" pitchFamily="34" charset="-120"/>
+              </a:rPr>
+              <a:t>A logistic regression is a standard statistical model for a yes/no outcome. Instead of predicting a number, it estimates the probability that something is true, and shows how that probability changes when one variable changes and the others are held fixed. It is widely used, simple to interpret and easy to reproduce.</a:t>
+            </a:r>
+            <a:endParaRPr lang="en-US" sz="1300" dirty="0"/>
+          </a:p>
+        </p:txBody>
+      </p:sp>
+      <p:sp>
+        <p:nvSpPr>
+          <p:cNvPr id="20" name="Shape 20"/>
+          <p:cNvSpPr/>
+          <p:nvPr/>
+        </p:nvSpPr>
+        <p:spPr>
+          <a:xfrm>
+            <a:off x="548640" y="2913888"/>
+            <a:ext cx="128016" cy="128016"/>
+          </a:xfrm>
+          <a:prstGeom prst="ellipse">
+            <a:avLst/>
+          </a:prstGeom>
+          <a:solidFill>
+            <a:srgbClr val="C1502F"/>
+          </a:solidFill>
+          <a:ln/>
+        </p:spPr>
+      </p:sp>
+      <p:sp>
+        <p:nvSpPr>
+          <p:cNvPr id="21" name="Text 21"/>
+          <p:cNvSpPr/>
+          <p:nvPr/>
+        </p:nvSpPr>
+        <p:spPr>
+          <a:xfrm>
+            <a:off x="822960" y="2895600"/>
+            <a:ext cx="2011680" cy="457200"/>
+          </a:xfrm>
+          <a:prstGeom prst="rect">
+            <a:avLst/>
+          </a:prstGeom>
+          <a:noFill/>
+          <a:ln/>
+        </p:spPr>
+        <p:txBody>
+          <a:bodyPr wrap="square" lIns="0" tIns="0" rIns="0" bIns="0" rtlCol="0" anchor="t"/>
+          <a:lstStyle/>
+          <a:p>
+            <a:pPr marL="0" indent="0">
+              <a:buNone/>
+            </a:pPr>
+            <a:r>
+              <a:rPr lang="en-US" sz="1200" b="1" kern="0" spc="100" dirty="0">
+                <a:solidFill>
+                  <a:srgbClr val="C1502F"/>
+                </a:solidFill>
+                <a:latin typeface="Calibri" pitchFamily="34" charset="0"/>
+                <a:ea typeface="Calibri" pitchFamily="34" charset="-122"/>
+                <a:cs typeface="Calibri" pitchFamily="34" charset="-120"/>
+              </a:rPr>
+              <a:t>THE OUTCOME</a:t>
+            </a:r>
+            <a:endParaRPr lang="en-US" sz="1200" dirty="0"/>
+          </a:p>
+        </p:txBody>
+      </p:sp>
+      <p:sp>
+        <p:nvSpPr>
+          <p:cNvPr id="22" name="Text 22"/>
+          <p:cNvSpPr/>
+          <p:nvPr/>
+        </p:nvSpPr>
+        <p:spPr>
+          <a:xfrm>
+            <a:off x="3017520" y="2895600"/>
+            <a:ext cx="8503920" cy="1097280"/>
+          </a:xfrm>
+          <a:prstGeom prst="rect">
+            <a:avLst/>
+          </a:prstGeom>
+          <a:noFill/>
+          <a:ln/>
+        </p:spPr>
+        <p:txBody>
+          <a:bodyPr wrap="square" lIns="0" tIns="0" rIns="0" bIns="0" rtlCol="0" anchor="t"/>
+          <a:lstStyle/>
+          <a:p>
+            <a:pPr marL="0" indent="0">
+              <a:lnSpc>
+                <a:spcPct val="125000"/>
+              </a:lnSpc>
+              <a:buNone/>
+            </a:pPr>
+            <a:r>
+              <a:rPr lang="en-US" sz="1300" dirty="0">
+                <a:solidFill>
+                  <a:srgbClr val="5B6B73"/>
+                </a:solidFill>
+                <a:latin typeface="Calibri" pitchFamily="34" charset="0"/>
+                <a:ea typeface="Calibri" pitchFamily="34" charset="-122"/>
+                <a:cs typeface="Calibri" pitchFamily="34" charset="-120"/>
+              </a:rPr>
+              <a:t>Whether a row has data at all. For each of the 148 district-months: does this district have a market price record — yes or no? The model is then run a second time with reporting as the outcome: was the district named in at least one humanitarian report that month?</a:t>
+            </a:r>
+            <a:endParaRPr lang="en-US" sz="1300" dirty="0"/>
+          </a:p>
+        </p:txBody>
+      </p:sp>
+      <p:sp>
+        <p:nvSpPr>
+          <p:cNvPr id="23" name="Shape 23"/>
+          <p:cNvSpPr/>
+          <p:nvPr/>
+        </p:nvSpPr>
+        <p:spPr>
+          <a:xfrm>
+            <a:off x="548640" y="4102608"/>
+            <a:ext cx="128016" cy="128016"/>
+          </a:xfrm>
+          <a:prstGeom prst="ellipse">
+            <a:avLst/>
+          </a:prstGeom>
+          <a:solidFill>
+            <a:srgbClr val="C1502F"/>
+          </a:solidFill>
+          <a:ln/>
+        </p:spPr>
+      </p:sp>
+      <p:sp>
+        <p:nvSpPr>
+          <p:cNvPr id="24" name="Text 24"/>
+          <p:cNvSpPr/>
+          <p:nvPr/>
+        </p:nvSpPr>
+        <p:spPr>
+          <a:xfrm>
+            <a:off x="822960" y="4084320"/>
+            <a:ext cx="2011680" cy="457200"/>
+          </a:xfrm>
+          <a:prstGeom prst="rect">
+            <a:avLst/>
+          </a:prstGeom>
+          <a:noFill/>
+          <a:ln/>
+        </p:spPr>
+        <p:txBody>
+          <a:bodyPr wrap="square" lIns="0" tIns="0" rIns="0" bIns="0" rtlCol="0" anchor="t"/>
+          <a:lstStyle/>
+          <a:p>
+            <a:pPr marL="0" indent="0">
+              <a:buNone/>
+            </a:pPr>
+            <a:r>
+              <a:rPr lang="en-US" sz="1200" b="1" kern="0" spc="100" dirty="0">
+                <a:solidFill>
+                  <a:srgbClr val="C1502F"/>
+                </a:solidFill>
+                <a:latin typeface="Calibri" pitchFamily="34" charset="0"/>
+                <a:ea typeface="Calibri" pitchFamily="34" charset="-122"/>
+                <a:cs typeface="Calibri" pitchFamily="34" charset="-120"/>
+              </a:rPr>
+              <a:t>THE VARIABLES</a:t>
+            </a:r>
+            <a:endParaRPr lang="en-US" sz="1200" dirty="0"/>
+          </a:p>
+        </p:txBody>
+      </p:sp>
+      <p:sp>
+        <p:nvSpPr>
+          <p:cNvPr id="25" name="Text 25"/>
+          <p:cNvSpPr/>
+          <p:nvPr/>
+        </p:nvSpPr>
+        <p:spPr>
+          <a:xfrm>
+            <a:off x="3017520" y="4084320"/>
+            <a:ext cx="8503920" cy="1097280"/>
+          </a:xfrm>
+          <a:prstGeom prst="rect">
+            <a:avLst/>
+          </a:prstGeom>
+          <a:noFill/>
+          <a:ln/>
+        </p:spPr>
+        <p:txBody>
+          <a:bodyPr wrap="square" lIns="0" tIns="0" rIns="0" bIns="0" rtlCol="0" anchor="t"/>
+          <a:lstStyle/>
+          <a:p>
+            <a:pPr marL="0" indent="0">
+              <a:lnSpc>
+                <a:spcPct val="125000"/>
+              </a:lnSpc>
+              <a:buNone/>
+            </a:pPr>
+            <a:r>
+              <a:rPr lang="en-US" sz="1300" dirty="0">
+                <a:solidFill>
+                  <a:srgbClr val="5B6B73"/>
+                </a:solidFill>
+                <a:latin typeface="Calibri" pitchFamily="34" charset="0"/>
+                <a:ea typeface="Calibri" pitchFamily="34" charset="-122"/>
+                <a:cs typeface="Calibri" pitchFamily="34" charset="-120"/>
+              </a:rPr>
+              <a:t>Conflict events in that district-month, district size in km², whether the district contains a major town, and the month itself. Population and road access can be added later if a reliable source is found. These are the characteristics that could plausibly explain why a place is monitored at all.</a:t>
+            </a:r>
+            <a:endParaRPr lang="en-US" sz="1300" dirty="0"/>
+          </a:p>
+        </p:txBody>
+      </p:sp>
+      <p:sp>
+        <p:nvSpPr>
+          <p:cNvPr id="26" name="Shape 26"/>
+          <p:cNvSpPr/>
+          <p:nvPr/>
+        </p:nvSpPr>
+        <p:spPr>
+          <a:xfrm>
+            <a:off x="548640" y="5291328"/>
+            <a:ext cx="128016" cy="128016"/>
+          </a:xfrm>
+          <a:prstGeom prst="ellipse">
+            <a:avLst/>
+          </a:prstGeom>
+          <a:solidFill>
+            <a:srgbClr val="C1502F"/>
+          </a:solidFill>
+          <a:ln/>
+        </p:spPr>
+      </p:sp>
+      <p:sp>
+        <p:nvSpPr>
+          <p:cNvPr id="27" name="Text 27"/>
+          <p:cNvSpPr/>
+          <p:nvPr/>
+        </p:nvSpPr>
+        <p:spPr>
+          <a:xfrm>
+            <a:off x="822960" y="5273040"/>
+            <a:ext cx="2011680" cy="457200"/>
+          </a:xfrm>
+          <a:prstGeom prst="rect">
+            <a:avLst/>
+          </a:prstGeom>
+          <a:noFill/>
+          <a:ln/>
+        </p:spPr>
+        <p:txBody>
+          <a:bodyPr wrap="square" lIns="0" tIns="0" rIns="0" bIns="0" rtlCol="0" anchor="t"/>
+          <a:lstStyle/>
+          <a:p>
+            <a:pPr marL="0" indent="0">
+              <a:buNone/>
+            </a:pPr>
+            <a:r>
+              <a:rPr lang="en-US" sz="1200" b="1" kern="0" spc="100" dirty="0">
+                <a:solidFill>
+                  <a:srgbClr val="C1502F"/>
+                </a:solidFill>
+                <a:latin typeface="Calibri" pitchFamily="34" charset="0"/>
+                <a:ea typeface="Calibri" pitchFamily="34" charset="-122"/>
+                <a:cs typeface="Calibri" pitchFamily="34" charset="-120"/>
+              </a:rPr>
+              <a:t>WHY A REGRESSION</a:t>
+            </a:r>
+            <a:endParaRPr lang="en-US" sz="1200" dirty="0"/>
+          </a:p>
+        </p:txBody>
+      </p:sp>
+      <p:sp>
+        <p:nvSpPr>
+          <p:cNvPr id="28" name="Text 28"/>
+          <p:cNvSpPr/>
+          <p:nvPr/>
+        </p:nvSpPr>
+        <p:spPr>
+          <a:xfrm>
+            <a:off x="3017520" y="5273040"/>
+            <a:ext cx="8503920" cy="1097280"/>
+          </a:xfrm>
+          <a:prstGeom prst="rect">
+            <a:avLst/>
+          </a:prstGeom>
+          <a:noFill/>
+          <a:ln/>
+        </p:spPr>
+        <p:txBody>
+          <a:bodyPr wrap="square" lIns="0" tIns="0" rIns="0" bIns="0" rtlCol="0" anchor="t"/>
+          <a:lstStyle/>
+          <a:p>
+            <a:pPr marL="0" indent="0">
+              <a:lnSpc>
+                <a:spcPct val="125000"/>
+              </a:lnSpc>
+              <a:buNone/>
+            </a:pPr>
+            <a:r>
+              <a:rPr lang="en-US" sz="1300" dirty="0">
+                <a:solidFill>
+                  <a:srgbClr val="5B6B73"/>
+                </a:solidFill>
+                <a:latin typeface="Calibri" pitchFamily="34" charset="0"/>
+                <a:ea typeface="Calibri" pitchFamily="34" charset="-122"/>
+                <a:cs typeface="Calibri" pitchFamily="34" charset="-120"/>
+              </a:rPr>
+              <a:t>Pilot analysis 1 compared one variable at a time, so it cannot separate explanations that move together — districts with markets also tend to be the districts with towns. A regression weighs the variables together and reports what each one contributes once the others are accounted for.</a:t>
+            </a:r>
+            <a:endParaRPr lang="en-US" sz="1300" dirty="0"/>
+          </a:p>
+        </p:txBody>
+      </p:sp>
+      <p:sp>
+        <p:nvSpPr>
+          <p:cNvPr id="29" name="Text 29"/>
+          <p:cNvSpPr/>
+          <p:nvPr/>
+        </p:nvSpPr>
+        <p:spPr>
+          <a:xfrm>
+            <a:off x="11548872" y="6400800"/>
+            <a:ext cx="365760" cy="274320"/>
+          </a:xfrm>
+          <a:prstGeom prst="rect">
+            <a:avLst/>
+          </a:prstGeom>
+          <a:noFill/>
+          <a:ln/>
+        </p:spPr>
+        <p:txBody>
+          <a:bodyPr wrap="square" lIns="0" tIns="0" rIns="0" bIns="0" rtlCol="0" anchor="ctr"/>
+          <a:lstStyle/>
+          <a:p>
+            <a:pPr marL="0" indent="0" algn="r">
+              <a:buNone/>
+            </a:pPr>
+            <a:r>
+              <a:rPr lang="en-US" sz="1000" dirty="0">
+                <a:solidFill>
+                  <a:srgbClr val="5B6B73"/>
+                </a:solidFill>
+                <a:latin typeface="Calibri" pitchFamily="34" charset="0"/>
+                <a:ea typeface="Calibri" pitchFamily="34" charset="-122"/>
+                <a:cs typeface="Calibri" pitchFamily="34" charset="-120"/>
+              </a:rPr>
+              <a:t>21</a:t>
+            </a:r>
+            <a:endParaRPr lang="en-US" sz="1000" dirty="0"/>
+          </a:p>
+        </p:txBody>
+      </p:sp>
+    </p:spTree>
+  </p:cSld>
+  <p:clrMapOvr>
+    <a:masterClrMapping/>
+  </p:clrMapOvr>
+</p:sld>
+</file>
+
+<file path=ppt/slides/slide22.xml><?xml version="1.0" encoding="utf-8"?>
+<p:sld xmlns:a="http://schemas.openxmlformats.org/drawingml/2006/main" xmlns:r="http://schemas.openxmlformats.org/officeDocument/2006/relationships" xmlns:p="http://schemas.openxmlformats.org/presentationml/2006/main">
+  <p:cSld>
+    <p:bg>
+      <p:bgPr>
+        <a:solidFill>
+          <a:srgbClr val="1B3A4B"/>
+        </a:solidFill>
+        <a:effectLst/>
+      </p:bgPr>
+    </p:bg>
+    <p:spTree>
+      <p:nvGrpSpPr>
+        <p:cNvPr id="1" name=""/>
+        <p:cNvGrpSpPr/>
+        <p:nvPr/>
+      </p:nvGrpSpPr>
+      <p:grpSpPr>
+        <a:xfrm>
+          <a:off x="0" y="0"/>
+          <a:ext cx="0" cy="0"/>
+          <a:chOff x="0" y="0"/>
+          <a:chExt cx="0" cy="0"/>
+        </a:xfrm>
+      </p:grpSpPr>
+      <p:sp>
+        <p:nvSpPr>
+          <p:cNvPr id="30" name="Text 30"/>
+          <p:cNvSpPr/>
+          <p:nvPr/>
+        </p:nvSpPr>
+        <p:spPr>
+          <a:xfrm>
+            <a:off x="822960" y="685800"/>
+            <a:ext cx="10058400" cy="365760"/>
+          </a:xfrm>
+          <a:prstGeom prst="rect">
+            <a:avLst/>
+          </a:prstGeom>
+          <a:noFill/>
+          <a:ln/>
+        </p:spPr>
+        <p:txBody>
+          <a:bodyPr wrap="square" lIns="0" tIns="0" rIns="0" bIns="0" rtlCol="0" anchor="ctr"/>
+          <a:lstStyle/>
+          <a:p>
+            <a:pPr marL="0" indent="0">
+              <a:buNone/>
+            </a:pPr>
+            <a:r>
+              <a:rPr lang="en-US" sz="1300" b="1" kern="0" spc="200" dirty="0">
+                <a:solidFill>
+                  <a:srgbClr val="E0876A"/>
+                </a:solidFill>
+                <a:latin typeface="Calibri" pitchFamily="34" charset="0"/>
+                <a:ea typeface="Calibri" pitchFamily="34" charset="-122"/>
+                <a:cs typeface="Calibri" pitchFamily="34" charset="-120"/>
+              </a:rPr>
+              <a:t>WHY THIS ANALYSIS MATTERS</a:t>
+            </a:r>
+            <a:endParaRPr lang="en-US" sz="1300" dirty="0"/>
+          </a:p>
+        </p:txBody>
+      </p:sp>
+      <p:sp>
+        <p:nvSpPr>
+          <p:cNvPr id="31" name="Text 31"/>
+          <p:cNvSpPr/>
+          <p:nvPr/>
+        </p:nvSpPr>
+        <p:spPr>
+          <a:xfrm>
+            <a:off x="822960" y="1097280"/>
+            <a:ext cx="10515600" cy="685800"/>
+          </a:xfrm>
+          <a:prstGeom prst="rect">
+            <a:avLst/>
+          </a:prstGeom>
+          <a:noFill/>
+          <a:ln/>
+        </p:spPr>
+        <p:txBody>
+          <a:bodyPr wrap="square" lIns="0" tIns="0" rIns="0" bIns="0" rtlCol="0" anchor="ctr"/>
+          <a:lstStyle/>
+          <a:p>
+            <a:pPr marL="0" indent="0">
+              <a:buNone/>
+            </a:pPr>
+            <a:r>
+              <a:rPr lang="en-US" sz="3000" b="1" dirty="0">
+                <a:solidFill>
+                  <a:srgbClr val="FFFFFF"/>
+                </a:solidFill>
+                <a:latin typeface="Cambria" pitchFamily="34" charset="0"/>
+                <a:ea typeface="Cambria" pitchFamily="34" charset="-122"/>
+                <a:cs typeface="Cambria" pitchFamily="34" charset="-120"/>
+              </a:rPr>
+              <a:t>Which districts are missing, not just how many</a:t>
+            </a:r>
+            <a:endParaRPr lang="en-US" sz="3000" dirty="0"/>
+          </a:p>
+        </p:txBody>
+      </p:sp>
+      <p:sp>
+        <p:nvSpPr>
+          <p:cNvPr id="32" name="Text 32"/>
+          <p:cNvSpPr/>
+          <p:nvPr/>
+        </p:nvSpPr>
+        <p:spPr>
+          <a:xfrm>
+            <a:off x="822960" y="1874520"/>
+            <a:ext cx="10515600" cy="640080"/>
+          </a:xfrm>
+          <a:prstGeom prst="rect">
+            <a:avLst/>
+          </a:prstGeom>
+          <a:noFill/>
+          <a:ln/>
+        </p:spPr>
+        <p:txBody>
+          <a:bodyPr wrap="square" lIns="0" tIns="0" rIns="0" bIns="0" rtlCol="0" anchor="ctr"/>
+          <a:lstStyle/>
+          <a:p>
+            <a:pPr marL="0" indent="0">
+              <a:lnSpc>
+                <a:spcPct val="125000"/>
+              </a:lnSpc>
+              <a:buNone/>
+            </a:pPr>
+            <a:r>
+              <a:rPr lang="en-US" sz="1500" i="1" dirty="0">
+                <a:solidFill>
+                  <a:srgbClr val="9FB4C0"/>
+                </a:solidFill>
+                <a:latin typeface="Calibri" pitchFamily="34" charset="0"/>
+                <a:ea typeface="Calibri" pitchFamily="34" charset="-122"/>
+                <a:cs typeface="Calibri" pitchFamily="34" charset="-120"/>
+              </a:rPr>
+              <a:t>Saying that market data covers 47% of districts describes the dataset. Saying which districts make up the missing 53% describes the humanitarian system that produced it.</a:t>
+            </a:r>
+            <a:endParaRPr lang="en-US" sz="1500" dirty="0"/>
+          </a:p>
+        </p:txBody>
+      </p:sp>
+      <p:sp>
+        <p:nvSpPr>
+          <p:cNvPr id="33" name="Shape 33"/>
+          <p:cNvSpPr/>
+          <p:nvPr/>
+        </p:nvSpPr>
+        <p:spPr>
+          <a:xfrm>
+            <a:off x="822960" y="2926080"/>
+            <a:ext cx="3332480" cy="2377440"/>
+          </a:xfrm>
+          <a:prstGeom prst="roundRect">
+            <a:avLst>
+              <a:gd name="adj" fmla="val 6000"/>
+            </a:avLst>
+          </a:prstGeom>
+          <a:solidFill>
+            <a:srgbClr val="26485C"/>
+          </a:solidFill>
+          <a:ln/>
+        </p:spPr>
+      </p:sp>
+      <p:sp>
+        <p:nvSpPr>
+          <p:cNvPr id="34" name="Text 34"/>
+          <p:cNvSpPr/>
+          <p:nvPr/>
+        </p:nvSpPr>
+        <p:spPr>
+          <a:xfrm>
+            <a:off x="1097280" y="3200400"/>
+            <a:ext cx="2783840" cy="320040"/>
+          </a:xfrm>
+          <a:prstGeom prst="rect">
+            <a:avLst/>
+          </a:prstGeom>
+          <a:noFill/>
+          <a:ln/>
+        </p:spPr>
+        <p:txBody>
+          <a:bodyPr wrap="square" lIns="0" tIns="0" rIns="0" bIns="0" rtlCol="0" anchor="t"/>
+          <a:lstStyle/>
+          <a:p>
+            <a:pPr marL="0" indent="0">
+              <a:buNone/>
+            </a:pPr>
+            <a:r>
+              <a:rPr lang="en-US" sz="1150" b="1" kern="0" spc="80" dirty="0">
+                <a:solidFill>
+                  <a:srgbClr val="E0876A"/>
+                </a:solidFill>
+                <a:latin typeface="Calibri" pitchFamily="34" charset="0"/>
+                <a:ea typeface="Calibri" pitchFamily="34" charset="-122"/>
+                <a:cs typeface="Calibri" pitchFamily="34" charset="-120"/>
+              </a:rPr>
+              <a:t>IF THE VARIABLES MATTER</a:t>
+            </a:r>
+            <a:endParaRPr lang="en-US" sz="1150" dirty="0"/>
+          </a:p>
+        </p:txBody>
+      </p:sp>
+      <p:sp>
+        <p:nvSpPr>
+          <p:cNvPr id="35" name="Text 35"/>
+          <p:cNvSpPr/>
+          <p:nvPr/>
+        </p:nvSpPr>
+        <p:spPr>
+          <a:xfrm>
+            <a:off x="1097280" y="3611880"/>
+            <a:ext cx="2783840" cy="1417320"/>
+          </a:xfrm>
+          <a:prstGeom prst="rect">
+            <a:avLst/>
+          </a:prstGeom>
+          <a:noFill/>
+          <a:ln/>
+        </p:spPr>
+        <p:txBody>
+          <a:bodyPr wrap="square" lIns="0" tIns="0" rIns="0" bIns="0" rtlCol="0" anchor="t"/>
+          <a:lstStyle/>
+          <a:p>
+            <a:pPr marL="0" indent="0">
+              <a:lnSpc>
+                <a:spcPct val="120000"/>
+              </a:lnSpc>
+              <a:buNone/>
+            </a:pPr>
+            <a:r>
+              <a:rPr lang="en-US" sz="1200" dirty="0">
+                <a:solidFill>
+                  <a:srgbClr val="F1E9DC"/>
+                </a:solidFill>
+                <a:latin typeface="Calibri" pitchFamily="34" charset="0"/>
+                <a:ea typeface="Calibri" pitchFamily="34" charset="-122"/>
+                <a:cs typeface="Calibri" pitchFamily="34" charset="-120"/>
+              </a:rPr>
+              <a:t>The gaps are systematic: the districts market and reporting data cannot see are a particular kind of district, and the dataset can say which kind. That is a finding about how humanitarian information is produced.</a:t>
+            </a:r>
+            <a:endParaRPr lang="en-US" sz="1200" dirty="0"/>
+          </a:p>
+        </p:txBody>
+      </p:sp>
+      <p:sp>
+        <p:nvSpPr>
+          <p:cNvPr id="36" name="Shape 36"/>
+          <p:cNvSpPr/>
+          <p:nvPr/>
+        </p:nvSpPr>
+        <p:spPr>
+          <a:xfrm>
+            <a:off x="4429760" y="2926080"/>
+            <a:ext cx="3332480" cy="2377440"/>
+          </a:xfrm>
+          <a:prstGeom prst="roundRect">
+            <a:avLst>
+              <a:gd name="adj" fmla="val 6000"/>
+            </a:avLst>
+          </a:prstGeom>
+          <a:solidFill>
+            <a:srgbClr val="26485C"/>
+          </a:solidFill>
+          <a:ln/>
+        </p:spPr>
+      </p:sp>
+      <p:sp>
+        <p:nvSpPr>
+          <p:cNvPr id="37" name="Text 37"/>
+          <p:cNvSpPr/>
+          <p:nvPr/>
+        </p:nvSpPr>
+        <p:spPr>
+          <a:xfrm>
+            <a:off x="4704080" y="3200400"/>
+            <a:ext cx="2783840" cy="320040"/>
+          </a:xfrm>
+          <a:prstGeom prst="rect">
+            <a:avLst/>
+          </a:prstGeom>
+          <a:noFill/>
+          <a:ln/>
+        </p:spPr>
+        <p:txBody>
+          <a:bodyPr wrap="square" lIns="0" tIns="0" rIns="0" bIns="0" rtlCol="0" anchor="t"/>
+          <a:lstStyle/>
+          <a:p>
+            <a:pPr marL="0" indent="0">
+              <a:buNone/>
+            </a:pPr>
+            <a:r>
+              <a:rPr lang="en-US" sz="1150" b="1" kern="0" spc="80" dirty="0">
+                <a:solidFill>
+                  <a:srgbClr val="E0876A"/>
+                </a:solidFill>
+                <a:latin typeface="Calibri" pitchFamily="34" charset="0"/>
+                <a:ea typeface="Calibri" pitchFamily="34" charset="-122"/>
+                <a:cs typeface="Calibri" pitchFamily="34" charset="-120"/>
+              </a:rPr>
+              <a:t>IF THEY DO NOT</a:t>
+            </a:r>
+            <a:endParaRPr lang="en-US" sz="1150" dirty="0"/>
+          </a:p>
+        </p:txBody>
+      </p:sp>
+      <p:sp>
+        <p:nvSpPr>
+          <p:cNvPr id="38" name="Text 38"/>
+          <p:cNvSpPr/>
+          <p:nvPr/>
+        </p:nvSpPr>
+        <p:spPr>
+          <a:xfrm>
+            <a:off x="4704080" y="3611880"/>
+            <a:ext cx="2783840" cy="1417320"/>
+          </a:xfrm>
+          <a:prstGeom prst="rect">
+            <a:avLst/>
+          </a:prstGeom>
+          <a:noFill/>
+          <a:ln/>
+        </p:spPr>
+        <p:txBody>
+          <a:bodyPr wrap="square" lIns="0" tIns="0" rIns="0" bIns="0" rtlCol="0" anchor="t"/>
+          <a:lstStyle/>
+          <a:p>
+            <a:pPr marL="0" indent="0">
+              <a:lnSpc>
+                <a:spcPct val="120000"/>
+              </a:lnSpc>
+              <a:buNone/>
+            </a:pPr>
+            <a:r>
+              <a:rPr lang="en-US" sz="1200" dirty="0">
+                <a:solidFill>
+                  <a:srgbClr val="F1E9DC"/>
+                </a:solidFill>
+                <a:latin typeface="Calibri" pitchFamily="34" charset="0"/>
+                <a:ea typeface="Calibri" pitchFamily="34" charset="-122"/>
+                <a:cs typeface="Calibri" pitchFamily="34" charset="-120"/>
+              </a:rPr>
+              <a:t>The gaps are not explained by conflict, size or urban status. Worth reporting too: it tells anyone using the dataset that a missing row is not a quiet signal of a worse-off district.</a:t>
+            </a:r>
+            <a:endParaRPr lang="en-US" sz="1200" dirty="0"/>
+          </a:p>
+        </p:txBody>
+      </p:sp>
+      <p:sp>
+        <p:nvSpPr>
+          <p:cNvPr id="39" name="Shape 39"/>
+          <p:cNvSpPr/>
+          <p:nvPr/>
+        </p:nvSpPr>
+        <p:spPr>
+          <a:xfrm>
+            <a:off x="8036560" y="2926080"/>
+            <a:ext cx="3332480" cy="2377440"/>
+          </a:xfrm>
+          <a:prstGeom prst="roundRect">
+            <a:avLst>
+              <a:gd name="adj" fmla="val 6000"/>
+            </a:avLst>
+          </a:prstGeom>
+          <a:solidFill>
+            <a:srgbClr val="26485C"/>
+          </a:solidFill>
+          <a:ln/>
+        </p:spPr>
+      </p:sp>
+      <p:sp>
+        <p:nvSpPr>
+          <p:cNvPr id="40" name="Text 40"/>
+          <p:cNvSpPr/>
+          <p:nvPr/>
+        </p:nvSpPr>
+        <p:spPr>
+          <a:xfrm>
+            <a:off x="8310880" y="3200400"/>
+            <a:ext cx="2783840" cy="320040"/>
+          </a:xfrm>
+          <a:prstGeom prst="rect">
+            <a:avLst/>
+          </a:prstGeom>
+          <a:noFill/>
+          <a:ln/>
+        </p:spPr>
+        <p:txBody>
+          <a:bodyPr wrap="square" lIns="0" tIns="0" rIns="0" bIns="0" rtlCol="0" anchor="t"/>
+          <a:lstStyle/>
+          <a:p>
+            <a:pPr marL="0" indent="0">
+              <a:buNone/>
+            </a:pPr>
+            <a:r>
+              <a:rPr lang="en-US" sz="1150" b="1" kern="0" spc="80" dirty="0">
+                <a:solidFill>
+                  <a:srgbClr val="E0876A"/>
+                </a:solidFill>
+                <a:latin typeface="Calibri" pitchFamily="34" charset="0"/>
+                <a:ea typeface="Calibri" pitchFamily="34" charset="-122"/>
+                <a:cs typeface="Calibri" pitchFamily="34" charset="-120"/>
+              </a:rPr>
+              <a:t>WHAT IT CANNOT SAY</a:t>
+            </a:r>
+            <a:endParaRPr lang="en-US" sz="1150" dirty="0"/>
+          </a:p>
+        </p:txBody>
+      </p:sp>
+      <p:sp>
+        <p:nvSpPr>
+          <p:cNvPr id="41" name="Text 41"/>
+          <p:cNvSpPr/>
+          <p:nvPr/>
+        </p:nvSpPr>
+        <p:spPr>
+          <a:xfrm>
+            <a:off x="8310880" y="3611880"/>
+            <a:ext cx="2783840" cy="1417320"/>
+          </a:xfrm>
+          <a:prstGeom prst="rect">
+            <a:avLst/>
+          </a:prstGeom>
+          <a:noFill/>
+          <a:ln/>
+        </p:spPr>
+        <p:txBody>
+          <a:bodyPr wrap="square" lIns="0" tIns="0" rIns="0" bIns="0" rtlCol="0" anchor="t"/>
+          <a:lstStyle/>
+          <a:p>
+            <a:pPr marL="0" indent="0">
+              <a:lnSpc>
+                <a:spcPct val="120000"/>
+              </a:lnSpc>
+              <a:buNone/>
+            </a:pPr>
+            <a:r>
+              <a:rPr lang="en-US" sz="1200" dirty="0">
+                <a:solidFill>
+                  <a:srgbClr val="F1E9DC"/>
+                </a:solidFill>
+                <a:latin typeface="Calibri" pitchFamily="34" charset="0"/>
+                <a:ea typeface="Calibri" pitchFamily="34" charset="-122"/>
+                <a:cs typeface="Calibri" pitchFamily="34" charset="-120"/>
+              </a:rPr>
+              <a:t>The model explains whether a record exists, not whether conditions were truly observed. A zero means nothing was recorded, not that nothing happened — and with two months, the result stays exploratory.</a:t>
+            </a:r>
+            <a:endParaRPr lang="en-US" sz="1200" dirty="0"/>
+          </a:p>
+        </p:txBody>
+      </p:sp>
+      <p:sp>
+        <p:nvSpPr>
+          <p:cNvPr id="42" name="Text 42"/>
+          <p:cNvSpPr/>
+          <p:nvPr/>
+        </p:nvSpPr>
+        <p:spPr>
+          <a:xfrm>
+            <a:off x="822960" y="5623560"/>
+            <a:ext cx="10515600" cy="457200"/>
+          </a:xfrm>
+          <a:prstGeom prst="rect">
+            <a:avLst/>
+          </a:prstGeom>
+          <a:noFill/>
+          <a:ln/>
+        </p:spPr>
+        <p:txBody>
+          <a:bodyPr wrap="square" lIns="0" tIns="0" rIns="0" bIns="0" rtlCol="0" anchor="ctr"/>
+          <a:lstStyle/>
+          <a:p>
+            <a:pPr marL="0" indent="0">
+              <a:lnSpc>
+                <a:spcPct val="130000"/>
+              </a:lnSpc>
+              <a:buNone/>
+            </a:pPr>
+            <a:r>
+              <a:rPr lang="en-US" sz="1350" b="1" dirty="0">
+                <a:solidFill>
+                  <a:srgbClr val="FFFFFF"/>
+                </a:solidFill>
+                <a:latin typeface="Calibri" pitchFamily="34" charset="0"/>
+                <a:ea typeface="Calibri" pitchFamily="34" charset="-122"/>
+                <a:cs typeface="Calibri" pitchFamily="34" charset="-120"/>
+              </a:rPr>
+              <a:t>Either way: </a:t>
+            </a:r>
+            <a:r>
+              <a:rPr lang="en-US" sz="1350" dirty="0">
+                <a:solidFill>
+                  <a:srgbClr val="F1E9DC"/>
+                </a:solidFill>
+                <a:latin typeface="Calibri" pitchFamily="34" charset="0"/>
+                <a:ea typeface="Calibri" pitchFamily="34" charset="-122"/>
+                <a:cs typeface="Calibri" pitchFamily="34" charset="-120"/>
+              </a:rPr>
+              <a:t>the answer speaks to the same question — how evenly do humanitarian sources observe different places, and what does that mean for anyone analysing food insecurity with them?</a:t>
+            </a:r>
+            <a:endParaRPr lang="en-US" sz="1350" dirty="0"/>
+          </a:p>
+        </p:txBody>
+      </p:sp>
+      <p:sp>
+        <p:nvSpPr>
+          <p:cNvPr id="43" name="Text 43"/>
+          <p:cNvSpPr/>
+          <p:nvPr/>
+        </p:nvSpPr>
+        <p:spPr>
+          <a:xfrm>
+            <a:off x="11548872" y="6400800"/>
+            <a:ext cx="365760" cy="274320"/>
+          </a:xfrm>
+          <a:prstGeom prst="rect">
+            <a:avLst/>
+          </a:prstGeom>
+          <a:noFill/>
+          <a:ln/>
+        </p:spPr>
+        <p:txBody>
+          <a:bodyPr wrap="square" lIns="0" tIns="0" rIns="0" bIns="0" rtlCol="0" anchor="ctr"/>
+          <a:lstStyle/>
+          <a:p>
+            <a:pPr marL="0" indent="0" algn="r">
+              <a:buNone/>
+            </a:pPr>
+            <a:r>
+              <a:rPr lang="en-US" sz="1000" dirty="0">
+                <a:solidFill>
+                  <a:srgbClr val="9FB4C0"/>
+                </a:solidFill>
+                <a:latin typeface="Calibri" pitchFamily="34" charset="0"/>
+                <a:ea typeface="Calibri" pitchFamily="34" charset="-122"/>
+                <a:cs typeface="Calibri" pitchFamily="34" charset="-120"/>
+              </a:rPr>
+              <a:t>22</a:t>
             </a:r>
             <a:endParaRPr lang="en-US" sz="1000" dirty="0"/>
           </a:p>

</xml_diff>